<commit_message>
fix(slides-pptx): make sort cards single drag objects
Each Sort It Out card was a separate rounded-rect shape + text box, so in
Google Slides the number dragged out of its box. Render each card as one
shape-with-text object (fill+line on the text box) so the box and number move
together when sorting. Regenerated all 74 decks + Desktop copies.
</commit_message>
<xml_diff>
--- a/lessons/1-1-flagship/slides.pptx
+++ b/lessons/1-1-flagship/slides.pptx
@@ -11107,7 +11107,7 @@
       </p:sp>
       <p:sp>
         <p:nvSpPr>
-          <p:cNvPr id="20" name="Shape 18"/>
+          <p:cNvPr id="20" name="Text 18"/>
           <p:cNvSpPr/>
           <p:nvPr/>
         </p:nvSpPr>
@@ -11128,33 +11128,7 @@
             <a:solidFill>
               <a:srgbClr val="D6DBDF"/>
             </a:solidFill>
-            <a:prstDash val="solid"/>
           </a:ln>
-          <a:effectLst>
-            <a:outerShdw sx="100000" sy="100000" kx="0" ky="0" algn="bl" rotWithShape="0" blurRad="50800" dist="12700" dir="5400000">
-              <a:srgbClr val="1C2E42">
-                <a:alpha val="10000"/>
-              </a:srgbClr>
-            </a:outerShdw>
-          </a:effectLst>
-        </p:spPr>
-      </p:sp>
-      <p:sp>
-        <p:nvSpPr>
-          <p:cNvPr id="21" name="Text 19"/>
-          <p:cNvSpPr/>
-          <p:nvPr/>
-        </p:nvSpPr>
-        <p:spPr>
-          <a:xfrm>
-            <a:off x="685800" y="1481328"/>
-            <a:ext cx="1447800" cy="384048"/>
-          </a:xfrm>
-          <a:prstGeom prst="rect">
-            <a:avLst/>
-          </a:prstGeom>
-          <a:noFill/>
-          <a:ln/>
         </p:spPr>
         <p:txBody>
           <a:bodyPr wrap="square" rtlCol="0" anchor="ctr"/>
@@ -11164,7 +11138,7 @@
               <a:buNone/>
             </a:pPr>
             <a:r>
-              <a:rPr lang="en-US" sz="900" dirty="0">
+              <a:rPr lang="en-US" sz="900" b="1" dirty="0">
                 <a:solidFill>
                   <a:srgbClr val="17324D"/>
                 </a:solidFill>
@@ -11180,7 +11154,7 @@
       </p:sp>
       <p:sp>
         <p:nvSpPr>
-          <p:cNvPr id="22" name="Shape 20"/>
+          <p:cNvPr id="21" name="Text 19"/>
           <p:cNvSpPr/>
           <p:nvPr/>
         </p:nvSpPr>
@@ -11201,33 +11175,7 @@
             <a:solidFill>
               <a:srgbClr val="D6DBDF"/>
             </a:solidFill>
-            <a:prstDash val="solid"/>
           </a:ln>
-          <a:effectLst>
-            <a:outerShdw sx="100000" sy="100000" kx="0" ky="0" algn="bl" rotWithShape="0" blurRad="50800" dist="12700" dir="5400000">
-              <a:srgbClr val="1C2E42">
-                <a:alpha val="10000"/>
-              </a:srgbClr>
-            </a:outerShdw>
-          </a:effectLst>
-        </p:spPr>
-      </p:sp>
-      <p:sp>
-        <p:nvSpPr>
-          <p:cNvPr id="23" name="Text 21"/>
-          <p:cNvSpPr/>
-          <p:nvPr/>
-        </p:nvSpPr>
-        <p:spPr>
-          <a:xfrm>
-            <a:off x="2453640" y="1481328"/>
-            <a:ext cx="1447800" cy="384048"/>
-          </a:xfrm>
-          <a:prstGeom prst="rect">
-            <a:avLst/>
-          </a:prstGeom>
-          <a:noFill/>
-          <a:ln/>
         </p:spPr>
         <p:txBody>
           <a:bodyPr wrap="square" rtlCol="0" anchor="ctr"/>
@@ -11237,7 +11185,7 @@
               <a:buNone/>
             </a:pPr>
             <a:r>
-              <a:rPr lang="en-US" sz="900" dirty="0">
+              <a:rPr lang="en-US" sz="900" b="1" dirty="0">
                 <a:solidFill>
                   <a:srgbClr val="17324D"/>
                 </a:solidFill>
@@ -11253,7 +11201,7 @@
       </p:sp>
       <p:sp>
         <p:nvSpPr>
-          <p:cNvPr id="24" name="Shape 22"/>
+          <p:cNvPr id="22" name="Text 20"/>
           <p:cNvSpPr/>
           <p:nvPr/>
         </p:nvSpPr>
@@ -11274,33 +11222,7 @@
             <a:solidFill>
               <a:srgbClr val="D6DBDF"/>
             </a:solidFill>
-            <a:prstDash val="solid"/>
           </a:ln>
-          <a:effectLst>
-            <a:outerShdw sx="100000" sy="100000" kx="0" ky="0" algn="bl" rotWithShape="0" blurRad="50800" dist="12700" dir="5400000">
-              <a:srgbClr val="1C2E42">
-                <a:alpha val="10000"/>
-              </a:srgbClr>
-            </a:outerShdw>
-          </a:effectLst>
-        </p:spPr>
-      </p:sp>
-      <p:sp>
-        <p:nvSpPr>
-          <p:cNvPr id="25" name="Text 23"/>
-          <p:cNvSpPr/>
-          <p:nvPr/>
-        </p:nvSpPr>
-        <p:spPr>
-          <a:xfrm>
-            <a:off x="4221480" y="1481328"/>
-            <a:ext cx="1447800" cy="384048"/>
-          </a:xfrm>
-          <a:prstGeom prst="rect">
-            <a:avLst/>
-          </a:prstGeom>
-          <a:noFill/>
-          <a:ln/>
         </p:spPr>
         <p:txBody>
           <a:bodyPr wrap="square" rtlCol="0" anchor="ctr"/>
@@ -11310,7 +11232,7 @@
               <a:buNone/>
             </a:pPr>
             <a:r>
-              <a:rPr lang="en-US" sz="900" dirty="0">
+              <a:rPr lang="en-US" sz="900" b="1" dirty="0">
                 <a:solidFill>
                   <a:srgbClr val="17324D"/>
                 </a:solidFill>
@@ -11326,7 +11248,7 @@
       </p:sp>
       <p:sp>
         <p:nvSpPr>
-          <p:cNvPr id="26" name="Shape 24"/>
+          <p:cNvPr id="23" name="Text 21"/>
           <p:cNvSpPr/>
           <p:nvPr/>
         </p:nvSpPr>
@@ -11347,33 +11269,7 @@
             <a:solidFill>
               <a:srgbClr val="D6DBDF"/>
             </a:solidFill>
-            <a:prstDash val="solid"/>
           </a:ln>
-          <a:effectLst>
-            <a:outerShdw sx="100000" sy="100000" kx="0" ky="0" algn="bl" rotWithShape="0" blurRad="50800" dist="12700" dir="5400000">
-              <a:srgbClr val="1C2E42">
-                <a:alpha val="10000"/>
-              </a:srgbClr>
-            </a:outerShdw>
-          </a:effectLst>
-        </p:spPr>
-      </p:sp>
-      <p:sp>
-        <p:nvSpPr>
-          <p:cNvPr id="27" name="Text 25"/>
-          <p:cNvSpPr/>
-          <p:nvPr/>
-        </p:nvSpPr>
-        <p:spPr>
-          <a:xfrm>
-            <a:off x="685800" y="1975104"/>
-            <a:ext cx="1447800" cy="384048"/>
-          </a:xfrm>
-          <a:prstGeom prst="rect">
-            <a:avLst/>
-          </a:prstGeom>
-          <a:noFill/>
-          <a:ln/>
         </p:spPr>
         <p:txBody>
           <a:bodyPr wrap="square" rtlCol="0" anchor="ctr"/>
@@ -11383,7 +11279,7 @@
               <a:buNone/>
             </a:pPr>
             <a:r>
-              <a:rPr lang="en-US" sz="900" dirty="0">
+              <a:rPr lang="en-US" sz="900" b="1" dirty="0">
                 <a:solidFill>
                   <a:srgbClr val="17324D"/>
                 </a:solidFill>
@@ -11399,7 +11295,7 @@
       </p:sp>
       <p:sp>
         <p:nvSpPr>
-          <p:cNvPr id="28" name="Shape 26"/>
+          <p:cNvPr id="24" name="Text 22"/>
           <p:cNvSpPr/>
           <p:nvPr/>
         </p:nvSpPr>
@@ -11420,33 +11316,7 @@
             <a:solidFill>
               <a:srgbClr val="D6DBDF"/>
             </a:solidFill>
-            <a:prstDash val="solid"/>
           </a:ln>
-          <a:effectLst>
-            <a:outerShdw sx="100000" sy="100000" kx="0" ky="0" algn="bl" rotWithShape="0" blurRad="50800" dist="12700" dir="5400000">
-              <a:srgbClr val="1C2E42">
-                <a:alpha val="10000"/>
-              </a:srgbClr>
-            </a:outerShdw>
-          </a:effectLst>
-        </p:spPr>
-      </p:sp>
-      <p:sp>
-        <p:nvSpPr>
-          <p:cNvPr id="29" name="Text 27"/>
-          <p:cNvSpPr/>
-          <p:nvPr/>
-        </p:nvSpPr>
-        <p:spPr>
-          <a:xfrm>
-            <a:off x="2453640" y="1975104"/>
-            <a:ext cx="1447800" cy="384048"/>
-          </a:xfrm>
-          <a:prstGeom prst="rect">
-            <a:avLst/>
-          </a:prstGeom>
-          <a:noFill/>
-          <a:ln/>
         </p:spPr>
         <p:txBody>
           <a:bodyPr wrap="square" rtlCol="0" anchor="ctr"/>
@@ -11456,7 +11326,7 @@
               <a:buNone/>
             </a:pPr>
             <a:r>
-              <a:rPr lang="en-US" sz="900" dirty="0">
+              <a:rPr lang="en-US" sz="900" b="1" dirty="0">
                 <a:solidFill>
                   <a:srgbClr val="17324D"/>
                 </a:solidFill>
@@ -11472,7 +11342,7 @@
       </p:sp>
       <p:sp>
         <p:nvSpPr>
-          <p:cNvPr id="30" name="Shape 28"/>
+          <p:cNvPr id="25" name="Text 23"/>
           <p:cNvSpPr/>
           <p:nvPr/>
         </p:nvSpPr>
@@ -11493,33 +11363,7 @@
             <a:solidFill>
               <a:srgbClr val="D6DBDF"/>
             </a:solidFill>
-            <a:prstDash val="solid"/>
           </a:ln>
-          <a:effectLst>
-            <a:outerShdw sx="100000" sy="100000" kx="0" ky="0" algn="bl" rotWithShape="0" blurRad="50800" dist="12700" dir="5400000">
-              <a:srgbClr val="1C2E42">
-                <a:alpha val="10000"/>
-              </a:srgbClr>
-            </a:outerShdw>
-          </a:effectLst>
-        </p:spPr>
-      </p:sp>
-      <p:sp>
-        <p:nvSpPr>
-          <p:cNvPr id="31" name="Text 29"/>
-          <p:cNvSpPr/>
-          <p:nvPr/>
-        </p:nvSpPr>
-        <p:spPr>
-          <a:xfrm>
-            <a:off x="4221480" y="1975104"/>
-            <a:ext cx="1447800" cy="384048"/>
-          </a:xfrm>
-          <a:prstGeom prst="rect">
-            <a:avLst/>
-          </a:prstGeom>
-          <a:noFill/>
-          <a:ln/>
         </p:spPr>
         <p:txBody>
           <a:bodyPr wrap="square" rtlCol="0" anchor="ctr"/>
@@ -11529,7 +11373,7 @@
               <a:buNone/>
             </a:pPr>
             <a:r>
-              <a:rPr lang="en-US" sz="900" dirty="0">
+              <a:rPr lang="en-US" sz="900" b="1" dirty="0">
                 <a:solidFill>
                   <a:srgbClr val="17324D"/>
                 </a:solidFill>
@@ -11545,7 +11389,7 @@
       </p:sp>
       <p:sp>
         <p:nvSpPr>
-          <p:cNvPr id="32" name="Shape 30"/>
+          <p:cNvPr id="26" name="Shape 24"/>
           <p:cNvSpPr/>
           <p:nvPr/>
         </p:nvSpPr>
@@ -11579,7 +11423,7 @@
       </p:sp>
       <p:sp>
         <p:nvSpPr>
-          <p:cNvPr id="33" name="Text 31"/>
+          <p:cNvPr id="27" name="Text 25"/>
           <p:cNvSpPr/>
           <p:nvPr/>
         </p:nvSpPr>
@@ -11620,7 +11464,7 @@
       </p:sp>
       <p:sp>
         <p:nvSpPr>
-          <p:cNvPr id="34" name="Shape 32"/>
+          <p:cNvPr id="28" name="Shape 26"/>
           <p:cNvSpPr/>
           <p:nvPr/>
         </p:nvSpPr>
@@ -11654,7 +11498,7 @@
       </p:sp>
       <p:sp>
         <p:nvSpPr>
-          <p:cNvPr id="35" name="Text 33"/>
+          <p:cNvPr id="29" name="Text 27"/>
           <p:cNvSpPr/>
           <p:nvPr/>
         </p:nvSpPr>
@@ -11695,7 +11539,7 @@
       </p:sp>
       <p:sp>
         <p:nvSpPr>
-          <p:cNvPr id="36" name="Shape 34"/>
+          <p:cNvPr id="30" name="Shape 28"/>
           <p:cNvSpPr/>
           <p:nvPr/>
         </p:nvSpPr>
@@ -11729,7 +11573,7 @@
       </p:sp>
       <p:sp>
         <p:nvSpPr>
-          <p:cNvPr id="37" name="Text 35"/>
+          <p:cNvPr id="31" name="Text 29"/>
           <p:cNvSpPr/>
           <p:nvPr/>
         </p:nvSpPr>
@@ -11770,7 +11614,7 @@
       </p:sp>
       <p:sp>
         <p:nvSpPr>
-          <p:cNvPr id="38" name="Text 36"/>
+          <p:cNvPr id="32" name="Text 30"/>
           <p:cNvSpPr/>
           <p:nvPr/>
         </p:nvSpPr>
@@ -11809,7 +11653,7 @@
       </p:sp>
       <p:sp>
         <p:nvSpPr>
-          <p:cNvPr id="39" name="Shape 37"/>
+          <p:cNvPr id="33" name="Shape 31"/>
           <p:cNvSpPr/>
           <p:nvPr/>
         </p:nvSpPr>
@@ -11832,7 +11676,7 @@
       </p:sp>
       <p:sp>
         <p:nvSpPr>
-          <p:cNvPr id="40" name="Shape 38"/>
+          <p:cNvPr id="34" name="Shape 32"/>
           <p:cNvSpPr/>
           <p:nvPr/>
         </p:nvSpPr>
@@ -11855,7 +11699,7 @@
       </p:sp>
       <p:sp>
         <p:nvSpPr>
-          <p:cNvPr id="41" name="Shape 39"/>
+          <p:cNvPr id="35" name="Shape 33"/>
           <p:cNvSpPr/>
           <p:nvPr/>
         </p:nvSpPr>
@@ -11878,7 +11722,7 @@
       </p:sp>
       <p:sp>
         <p:nvSpPr>
-          <p:cNvPr id="42" name="Shape 40"/>
+          <p:cNvPr id="36" name="Shape 34"/>
           <p:cNvSpPr/>
           <p:nvPr/>
         </p:nvSpPr>
@@ -11901,7 +11745,7 @@
       </p:sp>
       <p:sp>
         <p:nvSpPr>
-          <p:cNvPr id="43" name="Shape 41"/>
+          <p:cNvPr id="37" name="Shape 35"/>
           <p:cNvSpPr/>
           <p:nvPr/>
         </p:nvSpPr>

</xml_diff>